<commit_message>
Update live deployment URL to https://dealwise-ai.vercel.app across README, reports, presentations, and documents
</commit_message>
<xml_diff>
--- a/DEALWISE_AI_PRESENTATION.pptx
+++ b/DEALWISE_AI_PRESENTATION.pptx
@@ -3203,6 +3203,10 @@
             </a:r>
             <a:br/>
             <a:r>
+              <a:t>Live Web App: https://dealwise-ai.vercel.app/</a:t>
+            </a:r>
+            <a:br/>
+            <a:r>
               <a:t>Author: Panchaksharayya | October 2026</a:t>
             </a:r>
             <a:br/>
@@ -6778,7 +6782,7 @@
               </a:defRPr>
             </a:pPr>
             <a:r>
-              <a:t>• Live Application URL: http://localhost:5173</a:t>
+              <a:t>• Live Deployed Web Application: https://dealwise-ai.vercel.app/</a:t>
             </a:r>
           </a:p>
           <a:p>

</xml_diff>